<commit_message>
Rebuild the week 2 and 3 decks, which missed the cards merged in 2135b67
Meike's f70acdf, squashed into 2135b67 with PR #20, changed the card pages
and the notes: five research-methodology cards and a rulebook card in week 3,
and Rule 2 filled in on week 2. The presenter decks are generated from those
two sources and were not rebuilt afterwards, so week-03-deck.html still showed
five slides and week-02-deck.html still showed Rule 2 as a placeholder.

This is build_deck.py's output and nothing else. Week 3's PDF and PPTX are
committed for the first time, beside weeks 1 and 2. build_deck.py builds
weeks 1 and 2 when no week is named, so week 3 has to be asked for by number.

Co-Authored-By: Claude Opus 5 (1M context) <noreply@anthropic.com>
</commit_message>
<xml_diff>
--- a/project-documentation/slides/week-02-deck.pptx
+++ b/project-documentation/slides/week-02-deck.pptx
@@ -6930,12 +6930,28 @@
               </a:spcAft>
             </a:pPr>
             <a:r>
-              <a:rPr sz="1800" i="1">
-                <a:solidFill>
-                  <a:srgbClr val="6B7280"/>
-                </a:solidFill>
-              </a:rPr>
-              <a:t>Added together in the session.</a:t>
+              <a:rPr sz="1800">
+                <a:solidFill>
+                  <a:srgbClr val="111827"/>
+                </a:solidFill>
+              </a:rPr>
+              <a:t>Do something </a:t>
+            </a:r>
+            <a:r>
+              <a:rPr sz="1800" b="1">
+                <a:solidFill>
+                  <a:srgbClr val="111827"/>
+                </a:solidFill>
+              </a:rPr>
+              <a:t>weird</a:t>
+            </a:r>
+            <a:r>
+              <a:rPr sz="1800">
+                <a:solidFill>
+                  <a:srgbClr val="111827"/>
+                </a:solidFill>
+              </a:rPr>
+              <a:t>.</a:t>
             </a:r>
           </a:p>
         </p:txBody>

</xml_diff>

<commit_message>
Rebuild the week 2 and 3 decks, which missed the cards merged in 2135b67 (#23)
Meike's f70acdf, squashed into 2135b67 with PR #20, changed the card pages
and the notes: five research-methodology cards and a rulebook card in week 3,
and Rule 2 filled in on week 2. The presenter decks are generated from those
two sources and were not rebuilt afterwards, so week-03-deck.html still showed
five slides and week-02-deck.html still showed Rule 2 as a placeholder.

This is build_deck.py's output and nothing else. Week 3's PDF and PPTX are
committed for the first time, beside weeks 1 and 2. build_deck.py builds
weeks 1 and 2 when no week is named, so week 3 has to be asked for by number.

Co-authored-by: Claude Opus 5 (1M context) <noreply@anthropic.com>
</commit_message>
<xml_diff>
--- a/project-documentation/slides/week-02-deck.pptx
+++ b/project-documentation/slides/week-02-deck.pptx
@@ -6930,12 +6930,28 @@
               </a:spcAft>
             </a:pPr>
             <a:r>
-              <a:rPr sz="1800" i="1">
-                <a:solidFill>
-                  <a:srgbClr val="6B7280"/>
-                </a:solidFill>
-              </a:rPr>
-              <a:t>Added together in the session.</a:t>
+              <a:rPr sz="1800">
+                <a:solidFill>
+                  <a:srgbClr val="111827"/>
+                </a:solidFill>
+              </a:rPr>
+              <a:t>Do something </a:t>
+            </a:r>
+            <a:r>
+              <a:rPr sz="1800" b="1">
+                <a:solidFill>
+                  <a:srgbClr val="111827"/>
+                </a:solidFill>
+              </a:rPr>
+              <a:t>weird</a:t>
+            </a:r>
+            <a:r>
+              <a:rPr sz="1800">
+                <a:solidFill>
+                  <a:srgbClr val="111827"/>
+                </a:solidFill>
+              </a:rPr>
+              <a:t>.</a:t>
             </a:r>
           </a:p>
         </p:txBody>

</xml_diff>